<commit_message>
Adding comparison with multilingual-e5-small and benchmarking on Mr.TyDi-ar and MIRACL-ar datasets
</commit_message>
<xml_diff>
--- a/docs/thesis/fa/defense_slides.pptx
+++ b/docs/thesis/fa/defense_slides.pptx
@@ -22,6 +22,7 @@
     <p:sldId id="270" r:id="rId21"/>
     <p:sldId id="271" r:id="rId22"/>
     <p:sldId id="272" r:id="rId23"/>
+    <p:sldId id="273" r:id="rId24"/>
   </p:sldIdLst>
   <p:sldSz cx="12191695" cy="6858000" type="screen4x3"/>
   <p:notesSz cx="6858000" cy="9144000"/>
@@ -3505,7 +3506,19 @@
                 </a:solidFill>
                 <a:latin typeface="B Nazanin"/>
               </a:rPr>
-              <a:t>• SciFact (اجرا مستقیم):** SF+SPLADE 0.966 &gt; BM25 0.947 &gt; MiniLM-L6-v2 0.865</a:t>
+              <a:t>• SciFact:** SF+SPLADE 0.966 &gt; BM25 0.947 &gt; MiniLM 0.865</a:t>
+            </a:r>
+          </a:p>
+          <a:p>
+            <a:pPr algn="r"/>
+            <a:r>
+              <a:rPr sz="1800">
+                <a:solidFill>
+                  <a:srgbClr val="1F3B63"/>
+                </a:solidFill>
+                <a:latin typeface="B Nazanin"/>
+              </a:rPr>
+              <a:t>• E5-multi روی ۸ دیتاست اجرا شد — در ۶ مورد Best-SF جلوتر (جزئیات جدول ۴-۸)</a:t>
             </a:r>
           </a:p>
           <a:p>
@@ -3594,7 +3607,7 @@
                 </a:solidFill>
                 <a:latin typeface="B Nazanin"/>
               </a:rPr>
-              <a:t>آزمایش شبکه واژگان (WordNet): دو نسل، دو درس</a:t>
+              <a:t>بنچمارک‌های چندزبانه استاندارد عربی (TyDi / MIRACL)</a:t>
             </a:r>
           </a:p>
         </p:txBody>
@@ -3629,7 +3642,7 @@
                 </a:solidFill>
                 <a:latin typeface="B Nazanin"/>
               </a:rPr>
-              <a:t>• v1 جانشینی سطح-متن (γ=1):** افت معنادار MRR (p=0.024)</a:t>
+              <a:t>• پروتکل pooled-100: هر پرسش = سند مرتبط رسمی + ۹۹ نگتیو از کورپوس کامل</a:t>
             </a:r>
           </a:p>
           <a:p>
@@ -3641,7 +3654,7 @@
                 </a:solidFill>
                 <a:latin typeface="B Nazanin"/>
               </a:rPr>
-              <a:t>• علت: بیشترِ «OOV» فقط صورت جمع بود (borders→border) که لم‌سازی داخلی هندل می‌کرد</a:t>
+              <a:t>• TyDi-ar: SF=0.544 | BM25=0.881 | E5-multi=0.989</a:t>
             </a:r>
           </a:p>
           <a:p>
@@ -3653,7 +3666,7 @@
                 </a:solidFill>
                 <a:latin typeface="B Nazanin"/>
               </a:rPr>
-              <a:t>• v2 ادغام سطح-اثرانگشت (γ≤0.3) پس از لم‌سازی:** بی‌ضرر (p=0.53)، OOV حقیقی فقط ۱۴۹ پرسش</a:t>
+              <a:t>• MIRACL-ar: SF=0.542 | BM25=0.815 | E5=0.860</a:t>
             </a:r>
           </a:p>
           <a:p>
@@ -3665,7 +3678,19 @@
                 </a:solidFill>
                 <a:latin typeface="B Nazanin"/>
               </a:rPr>
-              <a:t>• درس طراحی: ادغام میرا در سطح اثرانگشت؛ سود اصلی در پیکره‌های با OOV واقعی بالا</a:t>
+              <a:t>• تفسیر صادقانه:** در ویکی‌پدیا بازدامنه، تراکمی چندزبانه غالب است؛</a:t>
+            </a:r>
+          </a:p>
+          <a:p>
+            <a:pPr algn="r"/>
+            <a:r>
+              <a:rPr sz="1700">
+                <a:solidFill>
+                  <a:srgbClr val="1F3B63"/>
+                </a:solidFill>
+                <a:latin typeface="B Nazanin"/>
+              </a:rPr>
+              <a:t>• نقطه قوت SF در دامنه بسته تخصصی (قرآن/دوزبانه دینی/SciFact) تأیید مجدد شد</a:t>
             </a:r>
           </a:p>
         </p:txBody>
@@ -3718,7 +3743,7 @@
                 </a:solidFill>
                 <a:latin typeface="B Nazanin"/>
               </a:rPr>
-              <a:t>مرزها و شکست‌ها</a:t>
+              <a:t>آزمایش شبکه واژگان (WordNet): دو نسل، دو درس</a:t>
             </a:r>
           </a:p>
         </p:txBody>
@@ -3747,49 +3772,49 @@
           <a:p>
             <a:pPr algn="r"/>
             <a:r>
-              <a:rPr sz="1900">
-                <a:solidFill>
-                  <a:srgbClr val="1F3B63"/>
-                </a:solidFill>
-                <a:latin typeface="B Nazanin"/>
-              </a:rPr>
-              <a:t>• cross-lingual محض بدون پل واژگانی: MRR=0.02 → راهکار: پیکره موازی دوزبانه</a:t>
-            </a:r>
-          </a:p>
-          <a:p>
-            <a:pPr algn="r"/>
-            <a:r>
-              <a:rPr sz="1900">
-                <a:solidFill>
-                  <a:srgbClr val="1F3B63"/>
-                </a:solidFill>
-                <a:latin typeface="B Nazanin"/>
-              </a:rPr>
-              <a:t>• multi-hop (MuSiQue): نیاز به سازوکار استدلال — کار آینده GAT</a:t>
-            </a:r>
-          </a:p>
-          <a:p>
-            <a:pPr algn="r"/>
-            <a:r>
-              <a:rPr sz="1900">
-                <a:solidFill>
-                  <a:srgbClr val="1F3B63"/>
-                </a:solidFill>
-                <a:latin typeface="B Nazanin"/>
-              </a:rPr>
-              <a:t>• PopQA موجودیت‌محور: BM25 قوی‌تر می‌ماند</a:t>
-            </a:r>
-          </a:p>
-          <a:p>
-            <a:pPr algn="r"/>
-            <a:r>
-              <a:rPr sz="1900">
-                <a:solidFill>
-                  <a:srgbClr val="1F3B63"/>
-                </a:solidFill>
-                <a:latin typeface="B Nazanin"/>
-              </a:rPr>
-              <a:t>• جهش اعداد انگلیسی تا حد زیادی از بزرگ‌شدن pool کاندید (top_k→100)</a:t>
+              <a:rPr sz="1700">
+                <a:solidFill>
+                  <a:srgbClr val="1F3B63"/>
+                </a:solidFill>
+                <a:latin typeface="B Nazanin"/>
+              </a:rPr>
+              <a:t>• v1 جانشینی سطح-متن (γ=1):** افت معنادار MRR (p=0.024)</a:t>
+            </a:r>
+          </a:p>
+          <a:p>
+            <a:pPr algn="r"/>
+            <a:r>
+              <a:rPr sz="1700">
+                <a:solidFill>
+                  <a:srgbClr val="1F3B63"/>
+                </a:solidFill>
+                <a:latin typeface="B Nazanin"/>
+              </a:rPr>
+              <a:t>• علت: بیشترِ «OOV» فقط صورت جمع بود (borders→border) که لم‌سازی داخلی هندل می‌کرد</a:t>
+            </a:r>
+          </a:p>
+          <a:p>
+            <a:pPr algn="r"/>
+            <a:r>
+              <a:rPr sz="1700">
+                <a:solidFill>
+                  <a:srgbClr val="1F3B63"/>
+                </a:solidFill>
+                <a:latin typeface="B Nazanin"/>
+              </a:rPr>
+              <a:t>• v2 ادغام سطح-اثرانگشت (γ≤0.3) پس از لم‌سازی:** بی‌ضرر (p=0.53)، OOV حقیقی فقط ۱۴۹ پرسش</a:t>
+            </a:r>
+          </a:p>
+          <a:p>
+            <a:pPr algn="r"/>
+            <a:r>
+              <a:rPr sz="1700">
+                <a:solidFill>
+                  <a:srgbClr val="1F3B63"/>
+                </a:solidFill>
+                <a:latin typeface="B Nazanin"/>
+              </a:rPr>
+              <a:t>• درس طراحی: ادغام میرا در سطح اثرانگشت؛ سود اصلی در پیکره‌های با OOV واقعی بالا</a:t>
             </a:r>
           </a:p>
         </p:txBody>
@@ -3842,7 +3867,7 @@
                 </a:solidFill>
                 <a:latin typeface="B Nazanin"/>
               </a:rPr>
-              <a:t>جمع‌بندی دستاوردها</a:t>
+              <a:t>مرزها و شکست‌ها</a:t>
             </a:r>
           </a:p>
         </p:txBody>
@@ -3877,7 +3902,7 @@
                 </a:solidFill>
                 <a:latin typeface="B Nazanin"/>
               </a:rPr>
-              <a:t>• خط لوله بازتولیدپذیر + چارچوب بنچمارک ۱۲ مجموعه‌داده‌ای</a:t>
+              <a:t>• cross-lingual محض بدون پل واژگانی: MRR=0.02 → راهکار: پیکره موازی دوزبانه</a:t>
             </a:r>
           </a:p>
           <a:p>
@@ -3889,7 +3914,7 @@
                 </a:solidFill>
                 <a:latin typeface="B Nazanin"/>
               </a:rPr>
-              <a:t>• MRR=1.000 در Belebele و NarrativeQA؛ برتری معنادار دوزبانه؛ قرآن ×۲–۳</a:t>
+              <a:t>• multi-hop (MuSiQue): نیاز به سازوکار استدلال — کار آینده GAT</a:t>
             </a:r>
           </a:p>
           <a:p>
@@ -3901,7 +3926,7 @@
                 </a:solidFill>
                 <a:latin typeface="B Nazanin"/>
               </a:rPr>
-              <a:t>• جدول ablation + آزمون‌های Wilcoxon/McNemar + تحلیل شکست</a:t>
+              <a:t>• PopQA موجودیت‌محور: BM25 قوی‌تر می‌ماند</a:t>
             </a:r>
           </a:p>
           <a:p>
@@ -3913,7 +3938,7 @@
                 </a:solidFill>
                 <a:latin typeface="B Nazanin"/>
               </a:rPr>
-              <a:t>• تعیین مرز طراحی شبکه واژگان با دو آزمایش کنترل‌شده</a:t>
+              <a:t>• جهش اعداد انگلیسی تا حد زیادی از بزرگ‌شدن pool کاندید (top_k→100)</a:t>
             </a:r>
           </a:p>
         </p:txBody>
@@ -3966,7 +3991,7 @@
                 </a:solidFill>
                 <a:latin typeface="B Nazanin"/>
               </a:rPr>
-              <a:t>کارهای آینده</a:t>
+              <a:t>جمع‌بندی دستاوردها</a:t>
             </a:r>
           </a:p>
         </p:txBody>
@@ -4001,7 +4026,7 @@
                 </a:solidFill>
                 <a:latin typeface="B Nazanin"/>
               </a:rPr>
-              <a:t>• گراف توجه (GAT) برای استدلال چند-hop و گراف دانش خودکار</a:t>
+              <a:t>• خط لوله بازتولیدپذیر + چارچوب بنچمارک ۱۴ مجموعه‌داده‌ای</a:t>
             </a:r>
           </a:p>
           <a:p>
@@ -4013,7 +4038,7 @@
                 </a:solidFill>
                 <a:latin typeface="B Nazanin"/>
               </a:rPr>
-              <a:t>• شبکه واژگان بین‌زبانی (BabelNet) برای cross-lingual واقعی</a:t>
+              <a:t>• MRR=1.000 در Belebele و NarrativeQA؛ برتری معنادار دوزبانه؛ قرآن ×۲–۳</a:t>
             </a:r>
           </a:p>
           <a:p>
@@ -4025,7 +4050,7 @@
                 </a:solidFill>
                 <a:latin typeface="B Nazanin"/>
               </a:rPr>
-              <a:t>• ریشه‌یابی عربی/انگلیسی؛ ارتباط معیاری؛ به‌روزرسانی پویا نقشه</a:t>
+              <a:t>• جدول ablation + آزمون‌های Wilcoxon/McNemar + تحلیل شکست</a:t>
             </a:r>
           </a:p>
           <a:p>
@@ -4037,7 +4062,7 @@
                 </a:solidFill>
                 <a:latin typeface="B Nazanin"/>
               </a:rPr>
-              <a:t>• گسترش مقایسه تراکمی به مدل‌های بزرگ‌تر (E5/mpnet)</a:t>
+              <a:t>• تعیین مرز طراحی شبکه واژگان با دو آزمایش کنترل‌شده</a:t>
             </a:r>
           </a:p>
         </p:txBody>
@@ -4068,6 +4093,130 @@
         </p:nvSpPr>
         <p:spPr>
           <a:xfrm>
+            <a:off x="365760" y="228600"/>
+            <a:ext cx="11430000" cy="822960"/>
+          </a:xfrm>
+          <a:prstGeom prst="rect">
+            <a:avLst/>
+          </a:prstGeom>
+          <a:noFill/>
+        </p:spPr>
+        <p:txBody>
+          <a:bodyPr wrap="square">
+            <a:spAutoFit/>
+          </a:bodyPr>
+          <a:lstStyle/>
+          <a:p>
+            <a:pPr algn="r"/>
+            <a:r>
+              <a:rPr sz="3000" b="1">
+                <a:solidFill>
+                  <a:srgbClr val="1F3B63"/>
+                </a:solidFill>
+                <a:latin typeface="B Nazanin"/>
+              </a:rPr>
+              <a:t>کارهای آینده</a:t>
+            </a:r>
+          </a:p>
+        </p:txBody>
+      </p:sp>
+      <p:sp>
+        <p:nvSpPr>
+          <p:cNvPr id="3" name="TextBox 2"/>
+          <p:cNvSpPr txBox="1"/>
+          <p:nvPr/>
+        </p:nvSpPr>
+        <p:spPr>
+          <a:xfrm>
+            <a:off x="548640" y="1188720"/>
+            <a:ext cx="11064240" cy="5303520"/>
+          </a:xfrm>
+          <a:prstGeom prst="rect">
+            <a:avLst/>
+          </a:prstGeom>
+          <a:noFill/>
+        </p:spPr>
+        <p:txBody>
+          <a:bodyPr wrap="square">
+            <a:spAutoFit/>
+          </a:bodyPr>
+          <a:lstStyle/>
+          <a:p>
+            <a:pPr algn="r"/>
+            <a:r>
+              <a:rPr sz="1900">
+                <a:solidFill>
+                  <a:srgbClr val="1F3B63"/>
+                </a:solidFill>
+                <a:latin typeface="B Nazanin"/>
+              </a:rPr>
+              <a:t>• گراف توجه (GAT) برای استدلال چند-hop و گراف دانش خودکار</a:t>
+            </a:r>
+          </a:p>
+          <a:p>
+            <a:pPr algn="r"/>
+            <a:r>
+              <a:rPr sz="1900">
+                <a:solidFill>
+                  <a:srgbClr val="1F3B63"/>
+                </a:solidFill>
+                <a:latin typeface="B Nazanin"/>
+              </a:rPr>
+              <a:t>• شبکه واژگان بین‌زبانی (BabelNet) برای cross-lingual واقعی</a:t>
+            </a:r>
+          </a:p>
+          <a:p>
+            <a:pPr algn="r"/>
+            <a:r>
+              <a:rPr sz="1900">
+                <a:solidFill>
+                  <a:srgbClr val="1F3B63"/>
+                </a:solidFill>
+                <a:latin typeface="B Nazanin"/>
+              </a:rPr>
+              <a:t>• ریشه‌یابی عربی/انگلیسی؛ ارتباط معیاری؛ به‌روزرسانی پویا نقشه</a:t>
+            </a:r>
+          </a:p>
+          <a:p>
+            <a:pPr algn="r"/>
+            <a:r>
+              <a:rPr sz="1900">
+                <a:solidFill>
+                  <a:srgbClr val="1F3B63"/>
+                </a:solidFill>
+                <a:latin typeface="B Nazanin"/>
+              </a:rPr>
+              <a:t>• گسترش مقایسه تراکمی به مدل‌های بزرگ‌تر (E5/mpnet)</a:t>
+            </a:r>
+          </a:p>
+        </p:txBody>
+      </p:sp>
+    </p:spTree>
+  </p:cSld>
+  <p:clrMapOvr>
+    <a:masterClrMapping/>
+  </p:clrMapOvr>
+</p:sld>
+</file>
+
+<file path=ppt/slides/slide18.xml><?xml version="1.0" encoding="utf-8"?>
+<p:sld xmlns:a="http://schemas.openxmlformats.org/drawingml/2006/main" xmlns:p="http://schemas.openxmlformats.org/presentationml/2006/main" xmlns:r="http://schemas.openxmlformats.org/officeDocument/2006/relationships">
+  <p:cSld>
+    <p:spTree>
+      <p:nvGrpSpPr>
+        <p:cNvPr id="1" name=""/>
+        <p:cNvGrpSpPr/>
+        <p:nvPr/>
+      </p:nvGrpSpPr>
+      <p:grpSpPr/>
+      <p:sp>
+        <p:nvSpPr>
+          <p:cNvPr id="2" name="TextBox 1"/>
+          <p:cNvSpPr txBox="1"/>
+          <p:nvPr/>
+        </p:nvSpPr>
+        <p:spPr>
+          <a:xfrm>
             <a:off x="914400" y="2743200"/>
             <a:ext cx="10332720" cy="1371600"/>
           </a:xfrm>
@@ -4699,6 +4848,18 @@
                 <a:latin typeface="B Nazanin"/>
               </a:rPr>
               <a:t>• انگلیسی عمومی:** Belebele، NarrativeQA، PubMedQA، PopQA، MuSiQue</a:t>
+            </a:r>
+          </a:p>
+          <a:p>
+            <a:pPr algn="r"/>
+            <a:r>
+              <a:rPr sz="1700">
+                <a:solidFill>
+                  <a:srgbClr val="1F3B63"/>
+                </a:solidFill>
+                <a:latin typeface="B Nazanin"/>
+              </a:rPr>
+              <a:t>• چندزبانه استاندارد:** Mr.TyDi-ar و MIRACL-ar (پروتکل pooled-100)</a:t>
             </a:r>
           </a:p>
           <a:p>

</xml_diff>